<commit_message>
Slop pass over the scientific deck and the short-oral deck
Scientific deck: the Aims bullets lead with verbs instead of nominalisations; the domain-ablation caption reads plainly; the Motivation and Aims bullets are trimmed so they no longer run into the footer band. Short oral: the first slide carries the submitted abstract title and its author list, as the Forum asks; a false range in the predictor line is a list; the transport line carries the source-ablation numbers instead of an aphorism.

Co-Authored-By: Claude Fable 5.1 <noreply@anthropic.com>
</commit_message>
<xml_diff>
--- a/docs/slides/MN-proxy-lightning-MNF2026.pptx
+++ b/docs/slides/MN-proxy-lightning-MNF2026.pptx
@@ -4582,7 +4582,7 @@
           <a:p>
             <a:r>
               <a:rPr lang="en-US" b="1" dirty="0" sz="2200"/>
-              <a:t>Which public data predict micronutrient deficiency? The same climate, soil and satellite layers hold across four African countries</a:t>
+              <a:t>Predicting Micronutrient Deficiency Prevalence in Sub-Saharan Africa Using Proxy Indicators: A Multi-country Machine Learning Framework</a:t>
             </a:r>
             <a:endParaRPr lang="bg-BG" dirty="0"/>
           </a:p>
@@ -4602,8 +4602,8 @@
         </p:nvSpPr>
         <p:spPr>
           <a:xfrm>
-            <a:off x="246888" y="1280160"/>
-            <a:ext cx="11704320" cy="411480"/>
+            <a:off x="246888" y="1234440"/>
+            <a:ext cx="11704320" cy="640080"/>
           </a:xfrm>
           <a:prstGeom prst="rect">
             <a:avLst/>
@@ -4617,7 +4617,7 @@
           <a:lstStyle/>
           <a:p>
             <a:r>
-              <a:rPr lang="en-US" sz="1600" dirty="0">
+              <a:rPr lang="en-US" sz="1200" dirty="0">
                 <a:solidFill>
                   <a:schemeClr val="tx1">
                     <a:lumMod val="65000"/>
@@ -4625,7 +4625,7 @@
                   </a:schemeClr>
                 </a:solidFill>
               </a:rPr>
-              <a:t>Andrew N. Mertens (University of California, Berkeley) and Sonja Y. Hess (University of California, Davis)</a:t>
+              <a:t>Andrew N. Mertens (presenting), Reed Atkin, Sorrel Namaste, Demewoz Haile, Kenneth H. Brown, Saskia Osendarp, Xiuping Tan, Eric Stewart, Keith Lividini, Seth Adu-Afarwuah, Nicolai Petry, Aminata S. Koroma, Mary H. Hodges, Fabian Rohner, Haddy Crookes, James P. Wirth, Jonathan Gorstein, Kathy Banke, Sonja Y. Hess</a:t>
             </a:r>
           </a:p>
         </p:txBody>
@@ -4646,7 +4646,7 @@
         </p:nvSpPr>
         <p:spPr>
           <a:xfrm>
-            <a:off x="246446" y="1737360"/>
+            <a:off x="246446" y="1920240"/>
             <a:ext cx="7038712" cy="606251"/>
           </a:xfrm>
           <a:prstGeom prst="rect">
@@ -4797,8 +4797,8 @@
         </p:nvSpPr>
         <p:spPr>
           <a:xfrm>
-            <a:off x="356616" y="2377440"/>
-            <a:ext cx="11338560" cy="3840480"/>
+            <a:off x="356616" y="2560320"/>
+            <a:ext cx="11338560" cy="3657600"/>
           </a:xfrm>
           <a:prstGeom prst="rect">
             <a:avLst/>
@@ -4993,7 +4993,7 @@
             </a:pPr>
             <a:r>
               <a:rPr lang="en-GB" sz="1800" dirty="0"/>
-              <a:t>Predictors: 454 public layers in 24 groups, from satellite imagery, climate and soil to crops, livestock, malaria, prices and household surveys.</a:t>
+              <a:t>Predictors: 454 public layers in 24 groups: satellite imagery, climate, soil, crops, livestock, malaria, prices and household surveys.</a:t>
             </a:r>
           </a:p>
           <a:p>
@@ -5327,7 +5327,7 @@
             </a:pPr>
             <a:r>
               <a:rPr lang="en-GB" sz="1600" dirty="0"/>
-              <a:t>In a country never surveyed: 0.26, positive in 17 of 22 country-outcome pairs. With climate and soil layers only: 0.37.</a:t>
+              <a:t>In a country never surveyed it scores 0.26, positive in 17 of 22 country-outcome pairs, and 0.37 with climate and soil layers only.</a:t>
             </a:r>
           </a:p>
           <a:p>
@@ -5338,7 +5338,7 @@
             </a:pPr>
             <a:r>
               <a:rPr lang="en-GB" sz="1600" dirty="0"/>
-              <a:t>Satellite, climate and soil layers carry 30 to 48 percent of the index, and the same gradient ranks worst on every deficiency: drier, grassier, poorer, more pastoral districts.</a:t>
+              <a:t>Satellite, climate and soil layers carry 30 to 48 percent of the index, and the same kind of district ranks worst on every deficiency: drier, grassier, poorer and more pastoral.</a:t>
             </a:r>
           </a:p>
           <a:p>
@@ -5349,7 +5349,7 @@
             </a:pPr>
             <a:r>
               <a:rPr lang="en-GB" sz="1600" dirty="0"/>
-              <a:t>Household-survey layers help at home and hurt abroad; the physical environment travels.</a:t>
+              <a:t>Household-survey layers help inside a country and hurt in a new one: dropping all 131 of them raises transport from 0.26 to 0.33.</a:t>
             </a:r>
           </a:p>
         </p:txBody>

</xml_diff>